<commit_message>
docs: update all docs, docx, pdf, and pptx with frontend, fixes, and accurate deployment info
</commit_message>
<xml_diff>
--- a/docs/Project-Presentation.pptx
+++ b/docs/Project-Presentation.pptx
@@ -4845,7 +4845,7 @@
                 <a:ea typeface="Calibri" pitchFamily="34" charset="-122"/>
                 <a:cs typeface="Calibri" pitchFamily="34" charset="-120"/>
               </a:rPr>
-              <a:t>Build 3 Images</a:t>
+              <a:t>Build 4 Images</a:t>
             </a:r>
             <a:endParaRPr lang="en-US" sz="1000" dirty="0"/>
           </a:p>
@@ -4965,7 +4965,7 @@
                 <a:ea typeface="Calibri" pitchFamily="34" charset="-122"/>
                 <a:cs typeface="Calibri" pitchFamily="34" charset="-120"/>
               </a:rPr>
-              <a:t>Python, Node.js, .NET built simultaneously.</a:t>
+              <a:t>Python, Node.js, .NET, and React frontend built simultaneously.</a:t>
             </a:r>
             <a:endParaRPr lang="en-US" sz="950" dirty="0"/>
           </a:p>
@@ -5149,7 +5149,7 @@
                 <a:ea typeface="Calibri" pitchFamily="34" charset="-122"/>
                 <a:cs typeface="Calibri" pitchFamily="34" charset="-120"/>
               </a:rPr>
-              <a:t>BLOCKS on CRITICAL/HIGH.</a:t>
+              <a:t>Reports CRITICAL/HIGH findings (non-blocking — artifacts published for review).</a:t>
             </a:r>
             <a:endParaRPr lang="en-US" sz="950" dirty="0"/>
           </a:p>
@@ -5277,7 +5277,7 @@
                 <a:ea typeface="Calibri" pitchFamily="34" charset="-122"/>
                 <a:cs typeface="Calibri" pitchFamily="34" charset="-120"/>
               </a:rPr>
-              <a:t>Only if ALL scans pass.</a:t>
+              <a:t>Only if Gates 1-3 pass (Trivy is informational).</a:t>
             </a:r>
             <a:endParaRPr lang="en-US" sz="950" dirty="0"/>
           </a:p>
@@ -8803,7 +8803,7 @@
                 <a:ea typeface="Calibri" pitchFamily="34" charset="-122"/>
                 <a:cs typeface="Calibri" pitchFamily="34" charset="-120"/>
               </a:rPr>
-              <a:t>Trivy 0.50.4</a:t>
+              <a:t>Trivy 0.70.0</a:t>
             </a:r>
             <a:endParaRPr lang="en-US" sz="1100" dirty="0"/>
           </a:p>
@@ -16825,7 +16825,7 @@
                 <a:ea typeface="Calibri" pitchFamily="34" charset="-122"/>
                 <a:cs typeface="Calibri" pitchFamily="34" charset="-120"/>
               </a:rPr>
-              <a:t>curl http://&lt;IP&gt;/health on each service — returns {status: healthy}</a:t>
+              <a:t>curl -k https://&lt;INGRESS-IP&gt;.nip.io/api/students, /api/courses, /api/reports — returns {status: healthy}</a:t>
             </a:r>
             <a:endParaRPr lang="en-US" sz="1100" dirty="0"/>
           </a:p>
@@ -22481,7 +22481,7 @@
                 <a:ea typeface="Calibri" pitchFamily="34" charset="-122"/>
                 <a:cs typeface="Calibri" pitchFamily="34" charset="-120"/>
               </a:rPr>
-              <a:t>What We Deployed: Three Microservices</a:t>
+              <a:t>What We Deployed: Four Microservices</a:t>
             </a:r>
             <a:endParaRPr lang="en-US" sz="2800" dirty="0"/>
           </a:p>
@@ -22545,7 +22545,7 @@
                 <a:ea typeface="Calibri" pitchFamily="34" charset="-122"/>
                 <a:cs typeface="Calibri" pitchFamily="34" charset="-120"/>
               </a:rPr>
-              <a:t>Three independent REST APIs — same function, three different programming languages. Proves the pipeline works for any language.</a:t>
+              <a:t>Four services — three REST APIs in different languages, plus a React frontend. Proves the pipeline works end-to-end from code to live web app.</a:t>
             </a:r>
             <a:endParaRPr lang="en-US" sz="1200" dirty="0"/>
           </a:p>
@@ -23948,7 +23948,7 @@
                 <a:ea typeface="Calibri" pitchFamily="34" charset="-122"/>
                 <a:cs typeface="Calibri" pitchFamily="34" charset="-120"/>
               </a:rPr>
-              <a:t>rg-gitops-project in Azure East US — logical container for all resources</a:t>
+              <a:t>rg-gitops-project in UK South — logical container for all resources</a:t>
             </a:r>
             <a:endParaRPr lang="en-US" sz="1050" dirty="0"/>
           </a:p>

</xml_diff>